<commit_message>
figures, slides: Figtree and a warm dark palette; 34 pt claims
</commit_message>
<xml_diff>
--- a/skills/slides/template/dark.pptx
+++ b/skills/slides/template/dark.pptx
@@ -221,7 +221,7 @@
         <p:spPr>
           <a:xfrm>
             <a:off x="457200" y="320040"/>
-            <a:ext cx="11277295" cy="1005840"/>
+            <a:ext cx="11277295" cy="1097280"/>
           </a:xfrm>
         </p:spPr>
         <p:txBody>
@@ -341,7 +341,7 @@
         <p:spPr>
           <a:xfrm>
             <a:off x="457200" y="320040"/>
-            <a:ext cx="11277295" cy="1005840"/>
+            <a:ext cx="11277295" cy="1097280"/>
           </a:xfrm>
         </p:spPr>
         <p:txBody>
@@ -555,7 +555,7 @@
         <p:spPr>
           <a:xfrm>
             <a:off x="457200" y="320040"/>
-            <a:ext cx="11277295" cy="1005840"/>
+            <a:ext cx="11277295" cy="1097280"/>
           </a:xfrm>
         </p:spPr>
         <p:txBody>
@@ -692,7 +692,7 @@
         <p:spPr>
           <a:xfrm>
             <a:off x="457200" y="320040"/>
-            <a:ext cx="11277295" cy="1005840"/>
+            <a:ext cx="11277295" cy="1097280"/>
           </a:xfrm>
         </p:spPr>
         <p:txBody>
@@ -847,7 +847,7 @@
         <p:spPr>
           <a:xfrm>
             <a:off x="457200" y="320040"/>
-            <a:ext cx="11277295" cy="1005840"/>
+            <a:ext cx="11277295" cy="1097280"/>
           </a:xfrm>
         </p:spPr>
         <p:txBody>
@@ -951,7 +951,7 @@
           <a:spcPts val="0"/>
         </a:spcBef>
         <a:buNone/>
-        <a:defRPr sz="2800">
+        <a:defRPr sz="3400">
           <a:solidFill>
             <a:schemeClr val="tx1"/>
           </a:solidFill>
@@ -1096,16 +1096,16 @@
   <a:themeElements>
     <a:clrScheme name="Dark">
       <a:dk1 xmlns:p="http://schemas.openxmlformats.org/presentationml/2006/main" xmlns:r="http://schemas.openxmlformats.org/officeDocument/2006/relationships">
-        <a:srgbClr val="111111"/>
+        <a:srgbClr val="11100E"/>
       </a:dk1>
       <a:lt1 xmlns:p="http://schemas.openxmlformats.org/presentationml/2006/main" xmlns:r="http://schemas.openxmlformats.org/officeDocument/2006/relationships">
-        <a:srgbClr val="E6E6E6"/>
+        <a:srgbClr val="F2EDE4"/>
       </a:lt1>
       <a:dk2 xmlns:p="http://schemas.openxmlformats.org/presentationml/2006/main" xmlns:r="http://schemas.openxmlformats.org/officeDocument/2006/relationships">
-        <a:srgbClr val="1C1C1C"/>
+        <a:srgbClr val="1C1A17"/>
       </a:dk2>
       <a:lt2 xmlns:p="http://schemas.openxmlformats.org/presentationml/2006/main" xmlns:r="http://schemas.openxmlformats.org/officeDocument/2006/relationships">
-        <a:srgbClr val="9A9A9A"/>
+        <a:srgbClr val="D9D2C5"/>
       </a:lt2>
       <a:accent1 xmlns:p="http://schemas.openxmlformats.org/presentationml/2006/main" xmlns:r="http://schemas.openxmlformats.org/officeDocument/2006/relationships">
         <a:srgbClr val="77AADD"/>
@@ -1123,18 +1123,18 @@
         <a:srgbClr val="EEDD88"/>
       </a:accent5>
       <a:accent6 xmlns:p="http://schemas.openxmlformats.org/presentationml/2006/main" xmlns:r="http://schemas.openxmlformats.org/officeDocument/2006/relationships">
-        <a:srgbClr val="4A4A4A"/>
+        <a:srgbClr val="4A4541"/>
       </a:accent6>
       <a:hlink xmlns:p="http://schemas.openxmlformats.org/presentationml/2006/main" xmlns:r="http://schemas.openxmlformats.org/officeDocument/2006/relationships">
         <a:srgbClr val="77AADD"/>
       </a:hlink>
       <a:folHlink xmlns:p="http://schemas.openxmlformats.org/presentationml/2006/main" xmlns:r="http://schemas.openxmlformats.org/officeDocument/2006/relationships">
-        <a:srgbClr val="9A9A9A"/>
+        <a:srgbClr val="D9D2C5"/>
       </a:folHlink>
     </a:clrScheme>
-    <a:fontScheme name="Source Sans 3">
+    <a:fontScheme name="Figtree">
       <a:majorFont>
-        <a:latin typeface="Source Sans 3 Semibold"/>
+        <a:latin typeface="Figtree SemiBold"/>
         <a:ea typeface=""/>
         <a:cs typeface=""/>
         <a:font script="Jpan" typeface="ＭＳ Ｐゴシック"/>
@@ -1169,7 +1169,7 @@
         <a:font script="Geor" typeface="Sylfaen"/>
       </a:majorFont>
       <a:minorFont>
-        <a:latin typeface="Source Sans 3"/>
+        <a:latin typeface="Figtree"/>
         <a:ea typeface=""/>
         <a:cs typeface=""/>
         <a:font script="Jpan" typeface="ＭＳ Ｐゴシック"/>

</xml_diff>